<commit_message>
feat(nodeslide): add semantic artifact specs and model gym
</commit_message>
<xml_diff>
--- a/outputs/artifact-atlas-v2/nodeslide-ultra-showcase-v2.pptx
+++ b/outputs/artifact-atlas-v2/nodeslide-ultra-showcase-v2.pptx
@@ -1608,7 +1608,7 @@
             <a:r>
               <a:rPr lang="en-US" dirty="0"/>
               <a:t>Artifact 25: interaction-clip
-Five real product states form a playable web sequence and a stepped PowerPoint fallback.
+Three captured product states anchor a five-step workflow and its PowerPoint fallback.
 Source: atlas-v2-interaction-clip
 Human preference: pending.</a:t>
             </a:r>
@@ -4157,7 +4157,7 @@
                 <a:ea typeface="Aptos Mono" pitchFamily="34" charset="-122"/>
                 <a:cs typeface="Aptos Mono" pitchFamily="34" charset="-120"/>
               </a:rPr>
-              <a:t>HARNESS V2 · SAME CONTROL ROUTE</a:t>
+              <a:t>HARNESS V2 · COVERAGE EXPANSION</a:t>
             </a:r>
             <a:endParaRPr lang="en-US" sz="1024" dirty="0"/>
           </a:p>
@@ -4362,9 +4362,50 @@
                 <a:ea typeface="Aptos" pitchFamily="34" charset="-122"/>
                 <a:cs typeface="Aptos" pitchFamily="34" charset="-120"/>
               </a:rPr>
-              <a:t>· browser / PPTX / PDF receipts</a:t>
+              <a:t>· browser / PPTX / PDF artifacts</a:t>
             </a:r>
             <a:endParaRPr lang="en-US" sz="1152" dirty="0"/>
+          </a:p>
+        </p:txBody>
+      </p:sp>
+      <p:sp>
+        <p:nvSpPr>
+          <p:cNvPr id="23" name="Text 21"/>
+          <p:cNvSpPr/>
+          <p:nvPr/>
+        </p:nvSpPr>
+        <p:spPr>
+          <a:xfrm>
+            <a:off x="3009900" y="5334000"/>
+            <a:ext cx="6172200" cy="213360"/>
+          </a:xfrm>
+          <a:prstGeom prst="rect">
+            <a:avLst/>
+          </a:prstGeom>
+          <a:noFill/>
+          <a:ln/>
+        </p:spPr>
+        <p:txBody>
+          <a:bodyPr wrap="square" lIns="0" tIns="0" rIns="0" bIns="0" rtlCol="0" anchor="t">
+            <a:normAutofit/>
+          </a:bodyPr>
+          <a:lstStyle/>
+          <a:p>
+            <a:pPr algn="ctr" indent="0" marL="0">
+              <a:buNone/>
+            </a:pPr>
+            <a:r>
+              <a:rPr lang="en-US" sz="960" b="1" dirty="0">
+                <a:solidFill>
+                  <a:srgbClr val="667069"/>
+                </a:solidFill>
+                <a:latin typeface="Aptos Mono" pitchFamily="34" charset="0"/>
+                <a:ea typeface="Aptos Mono" pitchFamily="34" charset="-122"/>
+                <a:cs typeface="Aptos Mono" pitchFamily="34" charset="-120"/>
+              </a:rPr>
+              <a:t>Coverage comparison only · no paired performance claim</a:t>
+            </a:r>
+            <a:endParaRPr lang="en-US" sz="960" dirty="0"/>
           </a:p>
         </p:txBody>
       </p:sp>
@@ -4649,7 +4690,7 @@
           <a:solidFill>
             <a:srgbClr val="3A7D44"/>
           </a:solidFill>
-          <a:ln w="6350">
+          <a:ln w="12700">
             <a:solidFill>
               <a:srgbClr val="3A7D44"/>
             </a:solidFill>
@@ -4741,7 +4782,48 @@
       </p:sp>
       <p:sp>
         <p:nvSpPr>
-          <p:cNvPr id="11" name="Shape 9"/>
+          <p:cNvPr id="11" name="Text 9"/>
+          <p:cNvSpPr/>
+          <p:nvPr/>
+        </p:nvSpPr>
+        <p:spPr>
+          <a:xfrm>
+            <a:off x="4000500" y="1905000"/>
+            <a:ext cx="1143000" cy="213360"/>
+          </a:xfrm>
+          <a:prstGeom prst="rect">
+            <a:avLst/>
+          </a:prstGeom>
+          <a:noFill/>
+          <a:ln/>
+        </p:spPr>
+        <p:txBody>
+          <a:bodyPr wrap="square" lIns="0" tIns="0" rIns="0" bIns="0" rtlCol="0" anchor="t">
+            <a:normAutofit/>
+          </a:bodyPr>
+          <a:lstStyle/>
+          <a:p>
+            <a:pPr algn="r" indent="0" marL="0">
+              <a:buNone/>
+            </a:pPr>
+            <a:r>
+              <a:rPr lang="en-US" sz="800" b="1" dirty="0">
+                <a:solidFill>
+                  <a:srgbClr val="3A7D44"/>
+                </a:solidFill>
+                <a:latin typeface="Aptos Mono" pitchFamily="34" charset="0"/>
+                <a:ea typeface="Aptos Mono" pitchFamily="34" charset="-122"/>
+                <a:cs typeface="Aptos Mono" pitchFamily="34" charset="-120"/>
+              </a:rPr>
+              <a:t>PASSED</a:t>
+            </a:r>
+            <a:endParaRPr lang="en-US" sz="800" dirty="0"/>
+          </a:p>
+        </p:txBody>
+      </p:sp>
+      <p:sp>
+        <p:nvSpPr>
+          <p:cNvPr id="12" name="Shape 10"/>
           <p:cNvSpPr/>
           <p:nvPr/>
         </p:nvSpPr>
@@ -4756,7 +4838,7 @@
           <a:solidFill>
             <a:srgbClr val="3A7D44"/>
           </a:solidFill>
-          <a:ln w="6350">
+          <a:ln w="12700">
             <a:solidFill>
               <a:srgbClr val="3A7D44"/>
             </a:solidFill>
@@ -4766,7 +4848,7 @@
       </p:sp>
       <p:sp>
         <p:nvSpPr>
-          <p:cNvPr id="12" name="Text 10"/>
+          <p:cNvPr id="13" name="Text 11"/>
           <p:cNvSpPr/>
           <p:nvPr/>
         </p:nvSpPr>
@@ -4807,7 +4889,7 @@
       </p:sp>
       <p:sp>
         <p:nvSpPr>
-          <p:cNvPr id="13" name="Text 11"/>
+          <p:cNvPr id="14" name="Text 12"/>
           <p:cNvSpPr/>
           <p:nvPr/>
         </p:nvSpPr>
@@ -4840,7 +4922,7 @@
                 <a:ea typeface="Aptos" pitchFamily="34" charset="-122"/>
                 <a:cs typeface="Aptos" pitchFamily="34" charset="-120"/>
               </a:rPr>
-              <a:t>Artifact type</a:t>
+              <a:t>Typed artifact spec</a:t>
             </a:r>
             <a:endParaRPr lang="en-US" sz="1280" dirty="0"/>
           </a:p>
@@ -4848,7 +4930,48 @@
       </p:sp>
       <p:sp>
         <p:nvSpPr>
-          <p:cNvPr id="14" name="Shape 12"/>
+          <p:cNvPr id="15" name="Text 13"/>
+          <p:cNvSpPr/>
+          <p:nvPr/>
+        </p:nvSpPr>
+        <p:spPr>
+          <a:xfrm>
+            <a:off x="4000500" y="2560320"/>
+            <a:ext cx="1143000" cy="213360"/>
+          </a:xfrm>
+          <a:prstGeom prst="rect">
+            <a:avLst/>
+          </a:prstGeom>
+          <a:noFill/>
+          <a:ln/>
+        </p:spPr>
+        <p:txBody>
+          <a:bodyPr wrap="square" lIns="0" tIns="0" rIns="0" bIns="0" rtlCol="0" anchor="t">
+            <a:normAutofit/>
+          </a:bodyPr>
+          <a:lstStyle/>
+          <a:p>
+            <a:pPr algn="r" indent="0" marL="0">
+              <a:buNone/>
+            </a:pPr>
+            <a:r>
+              <a:rPr lang="en-US" sz="800" b="1" dirty="0">
+                <a:solidFill>
+                  <a:srgbClr val="3A7D44"/>
+                </a:solidFill>
+                <a:latin typeface="Aptos Mono" pitchFamily="34" charset="0"/>
+                <a:ea typeface="Aptos Mono" pitchFamily="34" charset="-122"/>
+                <a:cs typeface="Aptos Mono" pitchFamily="34" charset="-120"/>
+              </a:rPr>
+              <a:t>PASSED</a:t>
+            </a:r>
+            <a:endParaRPr lang="en-US" sz="800" dirty="0"/>
+          </a:p>
+        </p:txBody>
+      </p:sp>
+      <p:sp>
+        <p:nvSpPr>
+          <p:cNvPr id="16" name="Shape 14"/>
           <p:cNvSpPr/>
           <p:nvPr/>
         </p:nvSpPr>
@@ -4863,7 +4986,7 @@
           <a:solidFill>
             <a:srgbClr val="3A7D44"/>
           </a:solidFill>
-          <a:ln w="6350">
+          <a:ln w="12700">
             <a:solidFill>
               <a:srgbClr val="3A7D44"/>
             </a:solidFill>
@@ -4873,7 +4996,7 @@
       </p:sp>
       <p:sp>
         <p:nvSpPr>
-          <p:cNvPr id="15" name="Text 13"/>
+          <p:cNvPr id="17" name="Text 15"/>
           <p:cNvSpPr/>
           <p:nvPr/>
         </p:nvSpPr>
@@ -4914,7 +5037,7 @@
       </p:sp>
       <p:sp>
         <p:nvSpPr>
-          <p:cNvPr id="16" name="Text 14"/>
+          <p:cNvPr id="18" name="Text 16"/>
           <p:cNvSpPr/>
           <p:nvPr/>
         </p:nvSpPr>
@@ -4947,7 +5070,7 @@
                 <a:ea typeface="Aptos" pitchFamily="34" charset="-122"/>
                 <a:cs typeface="Aptos" pitchFamily="34" charset="-120"/>
               </a:rPr>
-              <a:t>Allowed claims</a:t>
+              <a:t>Semantic validators</a:t>
             </a:r>
             <a:endParaRPr lang="en-US" sz="1280" dirty="0"/>
           </a:p>
@@ -4955,7 +5078,48 @@
       </p:sp>
       <p:sp>
         <p:nvSpPr>
-          <p:cNvPr id="17" name="Shape 15"/>
+          <p:cNvPr id="19" name="Text 17"/>
+          <p:cNvSpPr/>
+          <p:nvPr/>
+        </p:nvSpPr>
+        <p:spPr>
+          <a:xfrm>
+            <a:off x="4000500" y="3215640"/>
+            <a:ext cx="1143000" cy="213360"/>
+          </a:xfrm>
+          <a:prstGeom prst="rect">
+            <a:avLst/>
+          </a:prstGeom>
+          <a:noFill/>
+          <a:ln/>
+        </p:spPr>
+        <p:txBody>
+          <a:bodyPr wrap="square" lIns="0" tIns="0" rIns="0" bIns="0" rtlCol="0" anchor="t">
+            <a:normAutofit/>
+          </a:bodyPr>
+          <a:lstStyle/>
+          <a:p>
+            <a:pPr algn="r" indent="0" marL="0">
+              <a:buNone/>
+            </a:pPr>
+            <a:r>
+              <a:rPr lang="en-US" sz="800" b="1" dirty="0">
+                <a:solidFill>
+                  <a:srgbClr val="3A7D44"/>
+                </a:solidFill>
+                <a:latin typeface="Aptos Mono" pitchFamily="34" charset="0"/>
+                <a:ea typeface="Aptos Mono" pitchFamily="34" charset="-122"/>
+                <a:cs typeface="Aptos Mono" pitchFamily="34" charset="-120"/>
+              </a:rPr>
+              <a:t>PASSED</a:t>
+            </a:r>
+            <a:endParaRPr lang="en-US" sz="800" dirty="0"/>
+          </a:p>
+        </p:txBody>
+      </p:sp>
+      <p:sp>
+        <p:nvSpPr>
+          <p:cNvPr id="20" name="Shape 18"/>
           <p:cNvSpPr/>
           <p:nvPr/>
         </p:nvSpPr>
@@ -4970,7 +5134,7 @@
           <a:solidFill>
             <a:srgbClr val="3A7D44"/>
           </a:solidFill>
-          <a:ln w="6350">
+          <a:ln w="12700">
             <a:solidFill>
               <a:srgbClr val="3A7D44"/>
             </a:solidFill>
@@ -4980,7 +5144,7 @@
       </p:sp>
       <p:sp>
         <p:nvSpPr>
-          <p:cNvPr id="18" name="Text 16"/>
+          <p:cNvPr id="21" name="Text 19"/>
           <p:cNvSpPr/>
           <p:nvPr/>
         </p:nvSpPr>
@@ -5021,7 +5185,7 @@
       </p:sp>
       <p:sp>
         <p:nvSpPr>
-          <p:cNvPr id="19" name="Text 17"/>
+          <p:cNvPr id="22" name="Text 20"/>
           <p:cNvSpPr/>
           <p:nvPr/>
         </p:nvSpPr>
@@ -5054,7 +5218,7 @@
                 <a:ea typeface="Aptos" pitchFamily="34" charset="-122"/>
                 <a:cs typeface="Aptos" pitchFamily="34" charset="-120"/>
               </a:rPr>
-              <a:t>No forbidden claims</a:t>
+              <a:t>Source lineage</a:t>
             </a:r>
             <a:endParaRPr lang="en-US" sz="1280" dirty="0"/>
           </a:p>
@@ -5062,7 +5226,48 @@
       </p:sp>
       <p:sp>
         <p:nvSpPr>
-          <p:cNvPr id="20" name="Shape 18"/>
+          <p:cNvPr id="23" name="Text 21"/>
+          <p:cNvSpPr/>
+          <p:nvPr/>
+        </p:nvSpPr>
+        <p:spPr>
+          <a:xfrm>
+            <a:off x="4000500" y="3870960"/>
+            <a:ext cx="1143000" cy="213360"/>
+          </a:xfrm>
+          <a:prstGeom prst="rect">
+            <a:avLst/>
+          </a:prstGeom>
+          <a:noFill/>
+          <a:ln/>
+        </p:spPr>
+        <p:txBody>
+          <a:bodyPr wrap="square" lIns="0" tIns="0" rIns="0" bIns="0" rtlCol="0" anchor="t">
+            <a:normAutofit/>
+          </a:bodyPr>
+          <a:lstStyle/>
+          <a:p>
+            <a:pPr algn="r" indent="0" marL="0">
+              <a:buNone/>
+            </a:pPr>
+            <a:r>
+              <a:rPr lang="en-US" sz="800" b="1" dirty="0">
+                <a:solidFill>
+                  <a:srgbClr val="3A7D44"/>
+                </a:solidFill>
+                <a:latin typeface="Aptos Mono" pitchFamily="34" charset="0"/>
+                <a:ea typeface="Aptos Mono" pitchFamily="34" charset="-122"/>
+                <a:cs typeface="Aptos Mono" pitchFamily="34" charset="-120"/>
+              </a:rPr>
+              <a:t>PASSED</a:t>
+            </a:r>
+            <a:endParaRPr lang="en-US" sz="800" dirty="0"/>
+          </a:p>
+        </p:txBody>
+      </p:sp>
+      <p:sp>
+        <p:nvSpPr>
+          <p:cNvPr id="24" name="Shape 22"/>
           <p:cNvSpPr/>
           <p:nvPr/>
         </p:nvSpPr>
@@ -5077,7 +5282,7 @@
           <a:solidFill>
             <a:srgbClr val="3A7D44"/>
           </a:solidFill>
-          <a:ln w="6350">
+          <a:ln w="12700">
             <a:solidFill>
               <a:srgbClr val="3A7D44"/>
             </a:solidFill>
@@ -5087,7 +5292,7 @@
       </p:sp>
       <p:sp>
         <p:nvSpPr>
-          <p:cNvPr id="21" name="Text 19"/>
+          <p:cNvPr id="25" name="Text 23"/>
           <p:cNvSpPr/>
           <p:nvPr/>
         </p:nvSpPr>
@@ -5128,7 +5333,7 @@
       </p:sp>
       <p:sp>
         <p:nvSpPr>
-          <p:cNvPr id="22" name="Text 20"/>
+          <p:cNvPr id="26" name="Text 24"/>
           <p:cNvSpPr/>
           <p:nvPr/>
         </p:nvSpPr>
@@ -5161,7 +5366,7 @@
                 <a:ea typeface="Aptos" pitchFamily="34" charset="-122"/>
                 <a:cs typeface="Aptos" pitchFamily="34" charset="-120"/>
               </a:rPr>
-              <a:t>Zero collisions</a:t>
+              <a:t>Browser render</a:t>
             </a:r>
             <a:endParaRPr lang="en-US" sz="1280" dirty="0"/>
           </a:p>
@@ -5169,7 +5374,48 @@
       </p:sp>
       <p:sp>
         <p:nvSpPr>
-          <p:cNvPr id="23" name="Shape 21"/>
+          <p:cNvPr id="27" name="Text 25"/>
+          <p:cNvSpPr/>
+          <p:nvPr/>
+        </p:nvSpPr>
+        <p:spPr>
+          <a:xfrm>
+            <a:off x="4000500" y="4526280"/>
+            <a:ext cx="1143000" cy="213360"/>
+          </a:xfrm>
+          <a:prstGeom prst="rect">
+            <a:avLst/>
+          </a:prstGeom>
+          <a:noFill/>
+          <a:ln/>
+        </p:spPr>
+        <p:txBody>
+          <a:bodyPr wrap="square" lIns="0" tIns="0" rIns="0" bIns="0" rtlCol="0" anchor="t">
+            <a:normAutofit/>
+          </a:bodyPr>
+          <a:lstStyle/>
+          <a:p>
+            <a:pPr algn="r" indent="0" marL="0">
+              <a:buNone/>
+            </a:pPr>
+            <a:r>
+              <a:rPr lang="en-US" sz="800" b="1" dirty="0">
+                <a:solidFill>
+                  <a:srgbClr val="3A7D44"/>
+                </a:solidFill>
+                <a:latin typeface="Aptos Mono" pitchFamily="34" charset="0"/>
+                <a:ea typeface="Aptos Mono" pitchFamily="34" charset="-122"/>
+                <a:cs typeface="Aptos Mono" pitchFamily="34" charset="-120"/>
+              </a:rPr>
+              <a:t>PASSED</a:t>
+            </a:r>
+            <a:endParaRPr lang="en-US" sz="800" dirty="0"/>
+          </a:p>
+        </p:txBody>
+      </p:sp>
+      <p:sp>
+        <p:nvSpPr>
+          <p:cNvPr id="28" name="Shape 26"/>
           <p:cNvSpPr/>
           <p:nvPr/>
         </p:nvSpPr>
@@ -5184,7 +5430,7 @@
           <a:solidFill>
             <a:srgbClr val="3A7D44"/>
           </a:solidFill>
-          <a:ln w="6350">
+          <a:ln w="12700">
             <a:solidFill>
               <a:srgbClr val="3A7D44"/>
             </a:solidFill>
@@ -5194,7 +5440,7 @@
       </p:sp>
       <p:sp>
         <p:nvSpPr>
-          <p:cNvPr id="24" name="Text 22"/>
+          <p:cNvPr id="29" name="Text 27"/>
           <p:cNvSpPr/>
           <p:nvPr/>
         </p:nvSpPr>
@@ -5235,7 +5481,7 @@
       </p:sp>
       <p:sp>
         <p:nvSpPr>
-          <p:cNvPr id="25" name="Text 23"/>
+          <p:cNvPr id="30" name="Text 28"/>
           <p:cNvSpPr/>
           <p:nvPr/>
         </p:nvSpPr>
@@ -5268,7 +5514,7 @@
                 <a:ea typeface="Aptos" pitchFamily="34" charset="-122"/>
                 <a:cs typeface="Aptos" pitchFamily="34" charset="-120"/>
               </a:rPr>
-              <a:t>Browser render</a:t>
+              <a:t>PPTX render</a:t>
             </a:r>
             <a:endParaRPr lang="en-US" sz="1280" dirty="0"/>
           </a:p>
@@ -5276,7 +5522,48 @@
       </p:sp>
       <p:sp>
         <p:nvSpPr>
-          <p:cNvPr id="26" name="Shape 24"/>
+          <p:cNvPr id="31" name="Text 29"/>
+          <p:cNvSpPr/>
+          <p:nvPr/>
+        </p:nvSpPr>
+        <p:spPr>
+          <a:xfrm>
+            <a:off x="9182100" y="1905000"/>
+            <a:ext cx="1143000" cy="213360"/>
+          </a:xfrm>
+          <a:prstGeom prst="rect">
+            <a:avLst/>
+          </a:prstGeom>
+          <a:noFill/>
+          <a:ln/>
+        </p:spPr>
+        <p:txBody>
+          <a:bodyPr wrap="square" lIns="0" tIns="0" rIns="0" bIns="0" rtlCol="0" anchor="t">
+            <a:normAutofit/>
+          </a:bodyPr>
+          <a:lstStyle/>
+          <a:p>
+            <a:pPr algn="r" indent="0" marL="0">
+              <a:buNone/>
+            </a:pPr>
+            <a:r>
+              <a:rPr lang="en-US" sz="800" b="1" dirty="0">
+                <a:solidFill>
+                  <a:srgbClr val="3A7D44"/>
+                </a:solidFill>
+                <a:latin typeface="Aptos Mono" pitchFamily="34" charset="0"/>
+                <a:ea typeface="Aptos Mono" pitchFamily="34" charset="-122"/>
+                <a:cs typeface="Aptos Mono" pitchFamily="34" charset="-120"/>
+              </a:rPr>
+              <a:t>PASSED</a:t>
+            </a:r>
+            <a:endParaRPr lang="en-US" sz="800" dirty="0"/>
+          </a:p>
+        </p:txBody>
+      </p:sp>
+      <p:sp>
+        <p:nvSpPr>
+          <p:cNvPr id="32" name="Shape 30"/>
           <p:cNvSpPr/>
           <p:nvPr/>
         </p:nvSpPr>
@@ -5289,11 +5576,11 @@
             <a:avLst/>
           </a:prstGeom>
           <a:solidFill>
-            <a:srgbClr val="3A7D44"/>
+            <a:srgbClr val="FFFFFF"/>
           </a:solidFill>
-          <a:ln w="6350">
+          <a:ln w="12700">
             <a:solidFill>
-              <a:srgbClr val="3A7D44"/>
+              <a:srgbClr val="66727A"/>
             </a:solidFill>
             <a:prstDash val="solid"/>
           </a:ln>
@@ -5301,7 +5588,7 @@
       </p:sp>
       <p:sp>
         <p:nvSpPr>
-          <p:cNvPr id="27" name="Text 25"/>
+          <p:cNvPr id="33" name="Text 31"/>
           <p:cNvSpPr/>
           <p:nvPr/>
         </p:nvSpPr>
@@ -5328,13 +5615,13 @@
             <a:r>
               <a:rPr lang="en-US" sz="1088" b="1" dirty="0">
                 <a:solidFill>
-                  <a:srgbClr val="FFFFFF"/>
+                  <a:srgbClr val="66727A"/>
                 </a:solidFill>
                 <a:latin typeface="Aptos" pitchFamily="34" charset="0"/>
                 <a:ea typeface="Aptos" pitchFamily="34" charset="-122"/>
                 <a:cs typeface="Aptos" pitchFamily="34" charset="-120"/>
               </a:rPr>
-              <a:t>✓</a:t>
+              <a:t>·</a:t>
             </a:r>
             <a:endParaRPr lang="en-US" sz="1088" dirty="0"/>
           </a:p>
@@ -5342,7 +5629,7 @@
       </p:sp>
       <p:sp>
         <p:nvSpPr>
-          <p:cNvPr id="28" name="Text 26"/>
+          <p:cNvPr id="34" name="Text 32"/>
           <p:cNvSpPr/>
           <p:nvPr/>
         </p:nvSpPr>
@@ -5375,7 +5662,7 @@
                 <a:ea typeface="Aptos" pitchFamily="34" charset="-122"/>
                 <a:cs typeface="Aptos" pitchFamily="34" charset="-120"/>
               </a:rPr>
-              <a:t>PPTX render</a:t>
+              <a:t>Accessibility</a:t>
             </a:r>
             <a:endParaRPr lang="en-US" sz="1280" dirty="0"/>
           </a:p>
@@ -5383,7 +5670,48 @@
       </p:sp>
       <p:sp>
         <p:nvSpPr>
-          <p:cNvPr id="29" name="Shape 27"/>
+          <p:cNvPr id="35" name="Text 33"/>
+          <p:cNvSpPr/>
+          <p:nvPr/>
+        </p:nvSpPr>
+        <p:spPr>
+          <a:xfrm>
+            <a:off x="9182100" y="2560320"/>
+            <a:ext cx="1143000" cy="213360"/>
+          </a:xfrm>
+          <a:prstGeom prst="rect">
+            <a:avLst/>
+          </a:prstGeom>
+          <a:noFill/>
+          <a:ln/>
+        </p:spPr>
+        <p:txBody>
+          <a:bodyPr wrap="square" lIns="0" tIns="0" rIns="0" bIns="0" rtlCol="0" anchor="t">
+            <a:normAutofit/>
+          </a:bodyPr>
+          <a:lstStyle/>
+          <a:p>
+            <a:pPr algn="r" indent="0" marL="0">
+              <a:buNone/>
+            </a:pPr>
+            <a:r>
+              <a:rPr lang="en-US" sz="800" b="1" dirty="0">
+                <a:solidFill>
+                  <a:srgbClr val="66727A"/>
+                </a:solidFill>
+                <a:latin typeface="Aptos Mono" pitchFamily="34" charset="0"/>
+                <a:ea typeface="Aptos Mono" pitchFamily="34" charset="-122"/>
+                <a:cs typeface="Aptos Mono" pitchFamily="34" charset="-120"/>
+              </a:rPr>
+              <a:t>NOT RUN</a:t>
+            </a:r>
+            <a:endParaRPr lang="en-US" sz="800" dirty="0"/>
+          </a:p>
+        </p:txBody>
+      </p:sp>
+      <p:sp>
+        <p:nvSpPr>
+          <p:cNvPr id="36" name="Shape 34"/>
           <p:cNvSpPr/>
           <p:nvPr/>
         </p:nvSpPr>
@@ -5396,11 +5724,11 @@
             <a:avLst/>
           </a:prstGeom>
           <a:solidFill>
-            <a:srgbClr val="3A7D44"/>
+            <a:srgbClr val="FFFFFF"/>
           </a:solidFill>
-          <a:ln w="6350">
+          <a:ln w="12700">
             <a:solidFill>
-              <a:srgbClr val="3A7D44"/>
+              <a:srgbClr val="66727A"/>
             </a:solidFill>
             <a:prstDash val="solid"/>
           </a:ln>
@@ -5408,7 +5736,7 @@
       </p:sp>
       <p:sp>
         <p:nvSpPr>
-          <p:cNvPr id="30" name="Text 28"/>
+          <p:cNvPr id="37" name="Text 35"/>
           <p:cNvSpPr/>
           <p:nvPr/>
         </p:nvSpPr>
@@ -5435,13 +5763,13 @@
             <a:r>
               <a:rPr lang="en-US" sz="1088" b="1" dirty="0">
                 <a:solidFill>
-                  <a:srgbClr val="FFFFFF"/>
+                  <a:srgbClr val="66727A"/>
                 </a:solidFill>
                 <a:latin typeface="Aptos" pitchFamily="34" charset="0"/>
                 <a:ea typeface="Aptos" pitchFamily="34" charset="-122"/>
                 <a:cs typeface="Aptos" pitchFamily="34" charset="-120"/>
               </a:rPr>
-              <a:t>✓</a:t>
+              <a:t>·</a:t>
             </a:r>
             <a:endParaRPr lang="en-US" sz="1088" dirty="0"/>
           </a:p>
@@ -5449,7 +5777,7 @@
       </p:sp>
       <p:sp>
         <p:nvSpPr>
-          <p:cNvPr id="31" name="Text 29"/>
+          <p:cNvPr id="38" name="Text 36"/>
           <p:cNvSpPr/>
           <p:nvPr/>
         </p:nvSpPr>
@@ -5482,7 +5810,7 @@
                 <a:ea typeface="Aptos" pitchFamily="34" charset="-122"/>
                 <a:cs typeface="Aptos" pitchFamily="34" charset="-120"/>
               </a:rPr>
-              <a:t>Editable semantics</a:t>
+              <a:t>Visual inspection</a:t>
             </a:r>
             <a:endParaRPr lang="en-US" sz="1280" dirty="0"/>
           </a:p>
@@ -5490,7 +5818,48 @@
       </p:sp>
       <p:sp>
         <p:nvSpPr>
-          <p:cNvPr id="32" name="Shape 30"/>
+          <p:cNvPr id="39" name="Text 37"/>
+          <p:cNvSpPr/>
+          <p:nvPr/>
+        </p:nvSpPr>
+        <p:spPr>
+          <a:xfrm>
+            <a:off x="9182100" y="3215640"/>
+            <a:ext cx="1143000" cy="213360"/>
+          </a:xfrm>
+          <a:prstGeom prst="rect">
+            <a:avLst/>
+          </a:prstGeom>
+          <a:noFill/>
+          <a:ln/>
+        </p:spPr>
+        <p:txBody>
+          <a:bodyPr wrap="square" lIns="0" tIns="0" rIns="0" bIns="0" rtlCol="0" anchor="t">
+            <a:normAutofit/>
+          </a:bodyPr>
+          <a:lstStyle/>
+          <a:p>
+            <a:pPr algn="r" indent="0" marL="0">
+              <a:buNone/>
+            </a:pPr>
+            <a:r>
+              <a:rPr lang="en-US" sz="800" b="1" dirty="0">
+                <a:solidFill>
+                  <a:srgbClr val="66727A"/>
+                </a:solidFill>
+                <a:latin typeface="Aptos Mono" pitchFamily="34" charset="0"/>
+                <a:ea typeface="Aptos Mono" pitchFamily="34" charset="-122"/>
+                <a:cs typeface="Aptos Mono" pitchFamily="34" charset="-120"/>
+              </a:rPr>
+              <a:t>PENDING</a:t>
+            </a:r>
+            <a:endParaRPr lang="en-US" sz="800" dirty="0"/>
+          </a:p>
+        </p:txBody>
+      </p:sp>
+      <p:sp>
+        <p:nvSpPr>
+          <p:cNvPr id="40" name="Shape 38"/>
           <p:cNvSpPr/>
           <p:nvPr/>
         </p:nvSpPr>
@@ -5503,11 +5872,11 @@
             <a:avLst/>
           </a:prstGeom>
           <a:solidFill>
-            <a:srgbClr val="3A7D44"/>
+            <a:srgbClr val="FFFFFF"/>
           </a:solidFill>
-          <a:ln w="6350">
+          <a:ln w="12700">
             <a:solidFill>
-              <a:srgbClr val="3A7D44"/>
+              <a:srgbClr val="66727A"/>
             </a:solidFill>
             <a:prstDash val="solid"/>
           </a:ln>
@@ -5515,7 +5884,7 @@
       </p:sp>
       <p:sp>
         <p:nvSpPr>
-          <p:cNvPr id="33" name="Text 31"/>
+          <p:cNvPr id="41" name="Text 39"/>
           <p:cNvSpPr/>
           <p:nvPr/>
         </p:nvSpPr>
@@ -5542,13 +5911,13 @@
             <a:r>
               <a:rPr lang="en-US" sz="1088" b="1" dirty="0">
                 <a:solidFill>
-                  <a:srgbClr val="FFFFFF"/>
+                  <a:srgbClr val="66727A"/>
                 </a:solidFill>
                 <a:latin typeface="Aptos" pitchFamily="34" charset="0"/>
                 <a:ea typeface="Aptos" pitchFamily="34" charset="-122"/>
                 <a:cs typeface="Aptos" pitchFamily="34" charset="-120"/>
               </a:rPr>
-              <a:t>✓</a:t>
+              <a:t>·</a:t>
             </a:r>
             <a:endParaRPr lang="en-US" sz="1088" dirty="0"/>
           </a:p>
@@ -5556,7 +5925,7 @@
       </p:sp>
       <p:sp>
         <p:nvSpPr>
-          <p:cNvPr id="34" name="Text 32"/>
+          <p:cNvPr id="42" name="Text 40"/>
           <p:cNvSpPr/>
           <p:nvPr/>
         </p:nvSpPr>
@@ -5589,7 +5958,7 @@
                 <a:ea typeface="Aptos" pitchFamily="34" charset="-122"/>
                 <a:cs typeface="Aptos" pitchFamily="34" charset="-120"/>
               </a:rPr>
-              <a:t>Source lineage</a:t>
+              <a:t>Blind preference</a:t>
             </a:r>
             <a:endParaRPr lang="en-US" sz="1280" dirty="0"/>
           </a:p>
@@ -5597,57 +5966,32 @@
       </p:sp>
       <p:sp>
         <p:nvSpPr>
-          <p:cNvPr id="35" name="Shape 33"/>
-          <p:cNvSpPr/>
-          <p:nvPr/>
-        </p:nvSpPr>
-        <p:spPr>
-          <a:xfrm>
-            <a:off x="8153400" y="4495800"/>
-            <a:ext cx="3276600" cy="762000"/>
-          </a:xfrm>
-          <a:prstGeom prst="roundRect">
-            <a:avLst/>
-          </a:prstGeom>
-          <a:solidFill>
-            <a:srgbClr val="FFFFFF"/>
-          </a:solidFill>
-          <a:ln w="19050">
-            <a:solidFill>
-              <a:srgbClr val="145DA0"/>
-            </a:solidFill>
-            <a:prstDash val="solid"/>
-          </a:ln>
-        </p:spPr>
-      </p:sp>
-      <p:sp>
-        <p:nvSpPr>
-          <p:cNvPr id="36" name="Text 34"/>
-          <p:cNvSpPr/>
-          <p:nvPr/>
-        </p:nvSpPr>
-        <p:spPr>
-          <a:xfrm>
-            <a:off x="8343900" y="4663440"/>
-            <a:ext cx="2895600" cy="213360"/>
-          </a:xfrm>
-          <a:prstGeom prst="rect">
-            <a:avLst/>
-          </a:prstGeom>
-          <a:noFill/>
-          <a:ln/>
-        </p:spPr>
-        <p:txBody>
-          <a:bodyPr wrap="square" lIns="0" tIns="0" rIns="0" bIns="0" rtlCol="0" anchor="t">
-            <a:normAutofit/>
-          </a:bodyPr>
-          <a:lstStyle/>
-          <a:p>
-            <a:pPr algn="ctr" indent="0" marL="0">
-              <a:buNone/>
-            </a:pPr>
-            <a:r>
-              <a:rPr lang="en-US" sz="960" b="1" dirty="0">
+          <p:cNvPr id="43" name="Text 41"/>
+          <p:cNvSpPr/>
+          <p:nvPr/>
+        </p:nvSpPr>
+        <p:spPr>
+          <a:xfrm>
+            <a:off x="9182100" y="3870960"/>
+            <a:ext cx="1143000" cy="213360"/>
+          </a:xfrm>
+          <a:prstGeom prst="rect">
+            <a:avLst/>
+          </a:prstGeom>
+          <a:noFill/>
+          <a:ln/>
+        </p:spPr>
+        <p:txBody>
+          <a:bodyPr wrap="square" lIns="0" tIns="0" rIns="0" bIns="0" rtlCol="0" anchor="t">
+            <a:normAutofit/>
+          </a:bodyPr>
+          <a:lstStyle/>
+          <a:p>
+            <a:pPr algn="r" indent="0" marL="0">
+              <a:buNone/>
+            </a:pPr>
+            <a:r>
+              <a:rPr lang="en-US" sz="800" b="1" dirty="0">
                 <a:solidFill>
                   <a:srgbClr val="66727A"/>
                 </a:solidFill>
@@ -5655,50 +5999,9 @@
                 <a:ea typeface="Aptos Mono" pitchFamily="34" charset="-122"/>
                 <a:cs typeface="Aptos Mono" pitchFamily="34" charset="-120"/>
               </a:rPr>
-              <a:t>PREFERENCE</a:t>
-            </a:r>
-            <a:endParaRPr lang="en-US" sz="960" dirty="0"/>
-          </a:p>
-        </p:txBody>
-      </p:sp>
-      <p:sp>
-        <p:nvSpPr>
-          <p:cNvPr id="37" name="Text 35"/>
-          <p:cNvSpPr/>
-          <p:nvPr/>
-        </p:nvSpPr>
-        <p:spPr>
-          <a:xfrm>
-            <a:off x="8343900" y="4953000"/>
-            <a:ext cx="2895600" cy="198120"/>
-          </a:xfrm>
-          <a:prstGeom prst="rect">
-            <a:avLst/>
-          </a:prstGeom>
-          <a:noFill/>
-          <a:ln/>
-        </p:spPr>
-        <p:txBody>
-          <a:bodyPr wrap="square" lIns="0" tIns="0" rIns="0" bIns="0" rtlCol="0" anchor="t">
-            <a:normAutofit/>
-          </a:bodyPr>
-          <a:lstStyle/>
-          <a:p>
-            <a:pPr algn="ctr" indent="0" marL="0">
-              <a:buNone/>
-            </a:pPr>
-            <a:r>
-              <a:rPr lang="en-US" sz="1152" b="1" dirty="0">
-                <a:solidFill>
-                  <a:srgbClr val="145DA0"/>
-                </a:solidFill>
-                <a:latin typeface="Aptos" pitchFamily="34" charset="0"/>
-                <a:ea typeface="Aptos" pitchFamily="34" charset="-122"/>
-                <a:cs typeface="Aptos" pitchFamily="34" charset="-120"/>
-              </a:rPr>
-              <a:t>human review pending</a:t>
-            </a:r>
-            <a:endParaRPr lang="en-US" sz="1152" dirty="0"/>
+              <a:t>PENDING</a:t>
+            </a:r>
+            <a:endParaRPr lang="en-US" sz="800" dirty="0"/>
           </a:p>
         </p:txBody>
       </p:sp>
@@ -6040,8 +6343,8 @@
         </p:nvSpPr>
         <p:spPr>
           <a:xfrm flipV="1">
-            <a:off x="990600" y="3215640"/>
-            <a:ext cx="571500" cy="640080"/>
+            <a:off x="990600" y="3981450"/>
+            <a:ext cx="571500" cy="400050"/>
           </a:xfrm>
           <a:prstGeom prst="line">
             <a:avLst/>
@@ -6063,8 +6366,8 @@
         </p:nvSpPr>
         <p:spPr>
           <a:xfrm flipV="1">
-            <a:off x="1562100" y="3032760"/>
-            <a:ext cx="571500" cy="182880"/>
+            <a:off x="1562100" y="3867150"/>
+            <a:ext cx="571500" cy="114300"/>
           </a:xfrm>
           <a:prstGeom prst="line">
             <a:avLst/>
@@ -6086,8 +6389,8 @@
         </p:nvSpPr>
         <p:spPr>
           <a:xfrm flipV="1">
-            <a:off x="2133600" y="2667000"/>
-            <a:ext cx="571500" cy="365760"/>
+            <a:off x="2133600" y="3638550"/>
+            <a:ext cx="571500" cy="228600"/>
           </a:xfrm>
           <a:prstGeom prst="line">
             <a:avLst/>
@@ -6109,7 +6412,7 @@
         </p:nvSpPr>
         <p:spPr>
           <a:xfrm>
-            <a:off x="944880" y="3810000"/>
+            <a:off x="944880" y="4335780"/>
             <a:ext cx="91440" cy="91440"/>
           </a:xfrm>
           <a:prstGeom prst="ellipse">
@@ -6134,7 +6437,7 @@
         </p:nvSpPr>
         <p:spPr>
           <a:xfrm>
-            <a:off x="1516380" y="3169920"/>
+            <a:off x="1516380" y="3935730"/>
             <a:ext cx="91440" cy="91440"/>
           </a:xfrm>
           <a:prstGeom prst="ellipse">
@@ -6159,7 +6462,7 @@
         </p:nvSpPr>
         <p:spPr>
           <a:xfrm>
-            <a:off x="2087880" y="2987040"/>
+            <a:off x="2087880" y="3821430"/>
             <a:ext cx="91440" cy="91440"/>
           </a:xfrm>
           <a:prstGeom prst="ellipse">
@@ -6184,7 +6487,7 @@
         </p:nvSpPr>
         <p:spPr>
           <a:xfrm>
-            <a:off x="2659380" y="2621280"/>
+            <a:off x="2659380" y="3592830"/>
             <a:ext cx="91440" cy="91440"/>
           </a:xfrm>
           <a:prstGeom prst="ellipse">
@@ -6316,8 +6619,8 @@
         </p:nvSpPr>
         <p:spPr>
           <a:xfrm flipV="1">
-            <a:off x="3810000" y="2849880"/>
-            <a:ext cx="571500" cy="731520"/>
+            <a:off x="3810000" y="3752850"/>
+            <a:ext cx="571500" cy="457200"/>
           </a:xfrm>
           <a:prstGeom prst="line">
             <a:avLst/>
@@ -6339,8 +6642,8 @@
         </p:nvSpPr>
         <p:spPr>
           <a:xfrm flipV="1">
-            <a:off x="4381500" y="2575560"/>
-            <a:ext cx="571500" cy="274320"/>
+            <a:off x="4381500" y="3581400"/>
+            <a:ext cx="571500" cy="171450"/>
           </a:xfrm>
           <a:prstGeom prst="line">
             <a:avLst/>
@@ -6362,8 +6665,8 @@
         </p:nvSpPr>
         <p:spPr>
           <a:xfrm flipV="1">
-            <a:off x="4953000" y="2301240"/>
-            <a:ext cx="571500" cy="274320"/>
+            <a:off x="4953000" y="3409950"/>
+            <a:ext cx="571500" cy="171450"/>
           </a:xfrm>
           <a:prstGeom prst="line">
             <a:avLst/>
@@ -6385,7 +6688,7 @@
         </p:nvSpPr>
         <p:spPr>
           <a:xfrm>
-            <a:off x="3764280" y="3535680"/>
+            <a:off x="3764280" y="4164330"/>
             <a:ext cx="91440" cy="91440"/>
           </a:xfrm>
           <a:prstGeom prst="ellipse">
@@ -6410,7 +6713,7 @@
         </p:nvSpPr>
         <p:spPr>
           <a:xfrm>
-            <a:off x="4335780" y="2804160"/>
+            <a:off x="4335780" y="3707130"/>
             <a:ext cx="91440" cy="91440"/>
           </a:xfrm>
           <a:prstGeom prst="ellipse">
@@ -6435,7 +6738,7 @@
         </p:nvSpPr>
         <p:spPr>
           <a:xfrm>
-            <a:off x="4907280" y="2529840"/>
+            <a:off x="4907280" y="3535680"/>
             <a:ext cx="91440" cy="91440"/>
           </a:xfrm>
           <a:prstGeom prst="ellipse">
@@ -6460,7 +6763,7 @@
         </p:nvSpPr>
         <p:spPr>
           <a:xfrm>
-            <a:off x="5478780" y="2255520"/>
+            <a:off x="5478780" y="3364230"/>
             <a:ext cx="91440" cy="91440"/>
           </a:xfrm>
           <a:prstGeom prst="ellipse">
@@ -6578,7 +6881,7 @@
                 <a:ea typeface="Aptos Mono" pitchFamily="34" charset="-122"/>
                 <a:cs typeface="Aptos Mono" pitchFamily="34" charset="-120"/>
               </a:rPr>
-              <a:t>STATE 3 · Harness v4</a:t>
+              <a:t>STATE 3 · Harness v2</a:t>
             </a:r>
             <a:endParaRPr lang="en-US" sz="960" dirty="0"/>
           </a:p>
@@ -6592,8 +6895,8 @@
         </p:nvSpPr>
         <p:spPr>
           <a:xfrm flipV="1">
-            <a:off x="6629400" y="2484120"/>
-            <a:ext cx="571500" cy="822960"/>
+            <a:off x="6629400" y="3524250"/>
+            <a:ext cx="571500" cy="514350"/>
           </a:xfrm>
           <a:prstGeom prst="line">
             <a:avLst/>
@@ -6615,8 +6918,8 @@
         </p:nvSpPr>
         <p:spPr>
           <a:xfrm flipV="1">
-            <a:off x="7200900" y="2118360"/>
-            <a:ext cx="571500" cy="365760"/>
+            <a:off x="7200900" y="3295650"/>
+            <a:ext cx="571500" cy="228600"/>
           </a:xfrm>
           <a:prstGeom prst="line">
             <a:avLst/>
@@ -6638,8 +6941,8 @@
         </p:nvSpPr>
         <p:spPr>
           <a:xfrm flipV="1">
-            <a:off x="7772400" y="1935480"/>
-            <a:ext cx="571500" cy="182880"/>
+            <a:off x="7772400" y="3181350"/>
+            <a:ext cx="571500" cy="114300"/>
           </a:xfrm>
           <a:prstGeom prst="line">
             <a:avLst/>
@@ -6661,7 +6964,7 @@
         </p:nvSpPr>
         <p:spPr>
           <a:xfrm>
-            <a:off x="6583680" y="3261360"/>
+            <a:off x="6583680" y="3992880"/>
             <a:ext cx="91440" cy="91440"/>
           </a:xfrm>
           <a:prstGeom prst="ellipse">
@@ -6686,7 +6989,7 @@
         </p:nvSpPr>
         <p:spPr>
           <a:xfrm>
-            <a:off x="7155180" y="2438400"/>
+            <a:off x="7155180" y="3478530"/>
             <a:ext cx="91440" cy="91440"/>
           </a:xfrm>
           <a:prstGeom prst="ellipse">
@@ -6711,7 +7014,7 @@
         </p:nvSpPr>
         <p:spPr>
           <a:xfrm>
-            <a:off x="7726680" y="2072640"/>
+            <a:off x="7726680" y="3249930"/>
             <a:ext cx="91440" cy="91440"/>
           </a:xfrm>
           <a:prstGeom prst="ellipse">
@@ -6736,7 +7039,7 @@
         </p:nvSpPr>
         <p:spPr>
           <a:xfrm>
-            <a:off x="8298180" y="1889760"/>
+            <a:off x="8298180" y="3135630"/>
             <a:ext cx="91440" cy="91440"/>
           </a:xfrm>
           <a:prstGeom prst="ellipse">
@@ -6868,8 +7171,8 @@
         </p:nvSpPr>
         <p:spPr>
           <a:xfrm flipV="1">
-            <a:off x="9448800" y="2118360"/>
-            <a:ext cx="571500" cy="914400"/>
+            <a:off x="9448800" y="3295650"/>
+            <a:ext cx="571500" cy="571500"/>
           </a:xfrm>
           <a:prstGeom prst="line">
             <a:avLst/>
@@ -6891,8 +7194,8 @@
         </p:nvSpPr>
         <p:spPr>
           <a:xfrm flipV="1">
-            <a:off x="10020300" y="1661160"/>
-            <a:ext cx="571500" cy="457200"/>
+            <a:off x="10020300" y="3009900"/>
+            <a:ext cx="571500" cy="285750"/>
           </a:xfrm>
           <a:prstGeom prst="line">
             <a:avLst/>
@@ -6914,8 +7217,8 @@
         </p:nvSpPr>
         <p:spPr>
           <a:xfrm flipV="1">
-            <a:off x="10591800" y="1569720"/>
-            <a:ext cx="571500" cy="91440"/>
+            <a:off x="10591800" y="2952750"/>
+            <a:ext cx="571500" cy="57150"/>
           </a:xfrm>
           <a:prstGeom prst="line">
             <a:avLst/>
@@ -6937,7 +7240,7 @@
         </p:nvSpPr>
         <p:spPr>
           <a:xfrm>
-            <a:off x="9403080" y="2987040"/>
+            <a:off x="9403080" y="3821430"/>
             <a:ext cx="91440" cy="91440"/>
           </a:xfrm>
           <a:prstGeom prst="ellipse">
@@ -6962,7 +7265,7 @@
         </p:nvSpPr>
         <p:spPr>
           <a:xfrm>
-            <a:off x="9974580" y="2072640"/>
+            <a:off x="9974580" y="3249930"/>
             <a:ext cx="91440" cy="91440"/>
           </a:xfrm>
           <a:prstGeom prst="ellipse">
@@ -6987,7 +7290,7 @@
         </p:nvSpPr>
         <p:spPr>
           <a:xfrm>
-            <a:off x="10546080" y="1615440"/>
+            <a:off x="10546080" y="2964180"/>
             <a:ext cx="91440" cy="91440"/>
           </a:xfrm>
           <a:prstGeom prst="ellipse">
@@ -7012,7 +7315,7 @@
         </p:nvSpPr>
         <p:spPr>
           <a:xfrm>
-            <a:off x="11117580" y="1524000"/>
+            <a:off x="11117580" y="2907030"/>
             <a:ext cx="91440" cy="91440"/>
           </a:xfrm>
           <a:prstGeom prst="ellipse">
@@ -7067,6 +7370,47 @@
               <a:t>87 quality</a:t>
             </a:r>
             <a:endParaRPr lang="en-US" sz="1088" dirty="0"/>
+          </a:p>
+        </p:txBody>
+      </p:sp>
+      <p:sp>
+        <p:nvSpPr>
+          <p:cNvPr id="48" name="Text 46"/>
+          <p:cNvSpPr/>
+          <p:nvPr/>
+        </p:nvSpPr>
+        <p:spPr>
+          <a:xfrm>
+            <a:off x="723900" y="5151120"/>
+            <a:ext cx="10515600" cy="182880"/>
+          </a:xfrm>
+          <a:prstGeom prst="rect">
+            <a:avLst/>
+          </a:prstGeom>
+          <a:noFill/>
+          <a:ln/>
+        </p:spPr>
+        <p:txBody>
+          <a:bodyPr wrap="square" lIns="0" tIns="0" rIns="0" bIns="0" rtlCol="0" anchor="t">
+            <a:normAutofit/>
+          </a:bodyPr>
+          <a:lstStyle/>
+          <a:p>
+            <a:pPr algn="ctr" indent="0" marL="0">
+              <a:buNone/>
+            </a:pPr>
+            <a:r>
+              <a:rPr lang="en-US" sz="832" b="1" dirty="0">
+                <a:solidFill>
+                  <a:srgbClr val="A2B0C1"/>
+                </a:solidFill>
+                <a:latin typeface="Aptos Mono" pitchFamily="34" charset="0"/>
+                <a:ea typeface="Aptos Mono" pitchFamily="34" charset="-122"/>
+                <a:cs typeface="Aptos Mono" pitchFamily="34" charset="-120"/>
+              </a:rPr>
+              <a:t>Shared scale · 60–90 quality points</a:t>
+            </a:r>
+            <a:endParaRPr lang="en-US" sz="832" dirty="0"/>
           </a:p>
         </p:txBody>
       </p:sp>
@@ -9071,7 +9415,7 @@
                 <a:ea typeface="Aptos" pitchFamily="34" charset="-122"/>
                 <a:cs typeface="Aptos" pitchFamily="34" charset="-120"/>
               </a:rPr>
-              <a:t>38 reusable</a:t>
+              <a:t>V1 gallery</a:t>
             </a:r>
             <a:endParaRPr lang="en-US" sz="1152" dirty="0"/>
           </a:p>
@@ -9088,7 +9432,7 @@
                 <a:ea typeface="Aptos" pitchFamily="34" charset="-122"/>
                 <a:cs typeface="Aptos" pitchFamily="34" charset="-120"/>
               </a:rPr>
-              <a:t>patterns</a:t>
+              <a:t>12 patterns</a:t>
             </a:r>
             <a:endParaRPr lang="en-US" sz="1152" dirty="0"/>
           </a:p>
@@ -10842,7 +11186,7 @@
                 <a:ea typeface="Aptos Mono" pitchFamily="34" charset="-122"/>
                 <a:cs typeface="Aptos Mono" pitchFamily="34" charset="-120"/>
               </a:rPr>
-              <a:t>BRIEF → WINNER FUNNEL</a:t>
+              <a:t>FROZEN ARENA · CANDIDATE FUNNEL</a:t>
             </a:r>
             <a:endParaRPr lang="en-US" sz="1024" dirty="0"/>
           </a:p>
@@ -11182,7 +11526,7 @@
                 <a:ea typeface="Aptos" pitchFamily="34" charset="-122"/>
                 <a:cs typeface="Aptos" pitchFamily="34" charset="-120"/>
               </a:rPr>
-              <a:t>Human winner · 1</a:t>
+              <a:t>Prior human winner · 1</a:t>
             </a:r>
             <a:endParaRPr lang="en-US" sz="1088" dirty="0"/>
           </a:p>
@@ -11281,7 +11625,7 @@
               <a:buNone/>
             </a:pPr>
             <a:r>
-              <a:rPr lang="en-US" sz="1920" b="1" dirty="0">
+              <a:rPr lang="en-US" sz="1728" b="1" dirty="0">
                 <a:solidFill>
                   <a:srgbClr val="A64135"/>
                 </a:solidFill>
@@ -11289,9 +11633,9 @@
                 <a:ea typeface="Aptos" pitchFamily="34" charset="-122"/>
                 <a:cs typeface="Aptos" pitchFamily="34" charset="-120"/>
               </a:rPr>
-              <a:t>2 artifacts need repair</a:t>
-            </a:r>
-            <a:endParaRPr lang="en-US" sz="1920" dirty="0"/>
+              <a:t>2 Arena candidates failed gates</a:t>
+            </a:r>
+            <a:endParaRPr lang="en-US" sz="1728" dirty="0"/>
           </a:p>
         </p:txBody>
       </p:sp>
@@ -11322,7 +11666,7 @@
               <a:buNone/>
             </a:pPr>
             <a:r>
-              <a:rPr lang="en-US" sz="1216" dirty="0">
+              <a:rPr lang="en-US" sz="1152" dirty="0">
                 <a:solidFill>
                   <a:srgbClr val="102A2A"/>
                 </a:solidFill>
@@ -11330,9 +11674,9 @@
                 <a:ea typeface="Aptos" pitchFamily="34" charset="-122"/>
                 <a:cs typeface="Aptos" pitchFamily="34" charset="-120"/>
               </a:rPr>
-              <a:t>Both remain visibly red</a:t>
-            </a:r>
-            <a:endParaRPr lang="en-US" sz="1216" dirty="0"/>
+              <a:t>Historical result; not current Atlas status</a:t>
+            </a:r>
+            <a:endParaRPr lang="en-US" sz="1152" dirty="0"/>
           </a:p>
         </p:txBody>
       </p:sp>
@@ -12067,7 +12411,7 @@
                 <a:ea typeface="Aptos Mono" pitchFamily="34" charset="-122"/>
                 <a:cs typeface="Aptos Mono" pitchFamily="34" charset="-120"/>
               </a:rPr>
-              <a:t>Cost →</a:t>
+              <a:t>Observed cost per candidate →</a:t>
             </a:r>
             <a:endParaRPr lang="en-US" sz="960" dirty="0"/>
           </a:p>
@@ -12108,7 +12452,7 @@
                 <a:ea typeface="Aptos Mono" pitchFamily="34" charset="-122"/>
                 <a:cs typeface="Aptos Mono" pitchFamily="34" charset="-120"/>
               </a:rPr>
-              <a:t>Quality →</a:t>
+              <a:t>Eligible fraction →</a:t>
             </a:r>
             <a:endParaRPr lang="en-US" sz="960" dirty="0"/>
           </a:p>
@@ -12122,8 +12466,8 @@
         </p:nvSpPr>
         <p:spPr>
           <a:xfrm>
-            <a:off x="1783080" y="4069080"/>
-            <a:ext cx="396240" cy="396240"/>
+            <a:off x="1059180" y="3002280"/>
+            <a:ext cx="548640" cy="548640"/>
           </a:xfrm>
           <a:prstGeom prst="ellipse">
             <a:avLst/>
@@ -12149,8 +12493,8 @@
         </p:nvSpPr>
         <p:spPr>
           <a:xfrm>
-            <a:off x="1524000" y="4587240"/>
-            <a:ext cx="1371600" cy="228600"/>
+            <a:off x="647700" y="3733800"/>
+            <a:ext cx="2133600" cy="228600"/>
           </a:xfrm>
           <a:prstGeom prst="rect">
             <a:avLst/>
@@ -12168,7 +12512,7 @@
               <a:buNone/>
             </a:pPr>
             <a:r>
-              <a:rPr lang="en-US" sz="1024" b="1" dirty="0">
+              <a:rPr lang="en-US" sz="896" b="1" dirty="0">
                 <a:solidFill>
                   <a:srgbClr val="F4F1E8"/>
                 </a:solidFill>
@@ -12176,9 +12520,9 @@
                 <a:ea typeface="Aptos" pitchFamily="34" charset="-122"/>
                 <a:cs typeface="Aptos" pitchFamily="34" charset="-120"/>
               </a:rPr>
-              <a:t>Gemma · free</a:t>
-            </a:r>
-            <a:endParaRPr lang="en-US" sz="1024" dirty="0"/>
+              <a:t>Gemma · 23/24 · $0 · 17.3s</a:t>
+            </a:r>
+            <a:endParaRPr lang="en-US" sz="896" dirty="0"/>
           </a:p>
         </p:txBody>
       </p:sp>
@@ -12190,144 +12534,8 @@
         </p:nvSpPr>
         <p:spPr>
           <a:xfrm>
-            <a:off x="2941320" y="3436620"/>
-            <a:ext cx="518160" cy="518160"/>
-          </a:xfrm>
-          <a:prstGeom prst="ellipse">
-            <a:avLst/>
-          </a:prstGeom>
-          <a:solidFill>
-            <a:srgbClr val="A2B0C1">
-              <a:alpha val="82000"/>
-            </a:srgbClr>
-          </a:solidFill>
-          <a:ln w="25400">
-            <a:solidFill>
-              <a:srgbClr val="151F31"/>
-            </a:solidFill>
-            <a:prstDash val="solid"/>
-          </a:ln>
-        </p:spPr>
-      </p:sp>
-      <p:sp>
-        <p:nvSpPr>
-          <p:cNvPr id="20" name="Text 18"/>
-          <p:cNvSpPr/>
-          <p:nvPr/>
-        </p:nvSpPr>
-        <p:spPr>
-          <a:xfrm>
-            <a:off x="2743200" y="4076700"/>
-            <a:ext cx="1371600" cy="228600"/>
-          </a:xfrm>
-          <a:prstGeom prst="rect">
-            <a:avLst/>
-          </a:prstGeom>
-          <a:noFill/>
-          <a:ln/>
-        </p:spPr>
-        <p:txBody>
-          <a:bodyPr wrap="square" lIns="0" tIns="0" rIns="0" bIns="0" rtlCol="0" anchor="t">
-            <a:normAutofit/>
-          </a:bodyPr>
-          <a:lstStyle/>
-          <a:p>
-            <a:pPr algn="ctr" indent="0" marL="0">
-              <a:buNone/>
-            </a:pPr>
-            <a:r>
-              <a:rPr lang="en-US" sz="1024" b="1" dirty="0">
-                <a:solidFill>
-                  <a:srgbClr val="F4F1E8"/>
-                </a:solidFill>
-                <a:latin typeface="Aptos" pitchFamily="34" charset="0"/>
-                <a:ea typeface="Aptos" pitchFamily="34" charset="-122"/>
-                <a:cs typeface="Aptos" pitchFamily="34" charset="-120"/>
-              </a:rPr>
-              <a:t>GPT-OSS · free</a:t>
-            </a:r>
-            <a:endParaRPr lang="en-US" sz="1024" dirty="0"/>
-          </a:p>
-        </p:txBody>
-      </p:sp>
-      <p:sp>
-        <p:nvSpPr>
-          <p:cNvPr id="21" name="Shape 19"/>
-          <p:cNvSpPr/>
-          <p:nvPr/>
-        </p:nvSpPr>
-        <p:spPr>
-          <a:xfrm>
-            <a:off x="3977640" y="2987040"/>
-            <a:ext cx="579120" cy="579120"/>
-          </a:xfrm>
-          <a:prstGeom prst="ellipse">
-            <a:avLst/>
-          </a:prstGeom>
-          <a:solidFill>
-            <a:srgbClr val="A98BFF">
-              <a:alpha val="82000"/>
-            </a:srgbClr>
-          </a:solidFill>
-          <a:ln w="25400">
-            <a:solidFill>
-              <a:srgbClr val="151F31"/>
-            </a:solidFill>
-            <a:prstDash val="solid"/>
-          </a:ln>
-        </p:spPr>
-      </p:sp>
-      <p:sp>
-        <p:nvSpPr>
-          <p:cNvPr id="22" name="Text 20"/>
-          <p:cNvSpPr/>
-          <p:nvPr/>
-        </p:nvSpPr>
-        <p:spPr>
-          <a:xfrm>
-            <a:off x="3810000" y="3688080"/>
-            <a:ext cx="1371600" cy="228600"/>
-          </a:xfrm>
-          <a:prstGeom prst="rect">
-            <a:avLst/>
-          </a:prstGeom>
-          <a:noFill/>
-          <a:ln/>
-        </p:spPr>
-        <p:txBody>
-          <a:bodyPr wrap="square" lIns="0" tIns="0" rIns="0" bIns="0" rtlCol="0" anchor="t">
-            <a:normAutofit/>
-          </a:bodyPr>
-          <a:lstStyle/>
-          <a:p>
-            <a:pPr algn="ctr" indent="0" marL="0">
-              <a:buNone/>
-            </a:pPr>
-            <a:r>
-              <a:rPr lang="en-US" sz="1024" b="1" dirty="0">
-                <a:solidFill>
-                  <a:srgbClr val="F4F1E8"/>
-                </a:solidFill>
-                <a:latin typeface="Aptos" pitchFamily="34" charset="0"/>
-                <a:ea typeface="Aptos" pitchFamily="34" charset="-122"/>
-                <a:cs typeface="Aptos" pitchFamily="34" charset="-120"/>
-              </a:rPr>
-              <a:t>Nemotron · free</a:t>
-            </a:r>
-            <a:endParaRPr lang="en-US" sz="1024" dirty="0"/>
-          </a:p>
-        </p:txBody>
-      </p:sp>
-      <p:sp>
-        <p:nvSpPr>
-          <p:cNvPr id="23" name="Shape 21"/>
-          <p:cNvSpPr/>
-          <p:nvPr/>
-        </p:nvSpPr>
-        <p:spPr>
-          <a:xfrm>
-            <a:off x="5455920" y="2446020"/>
-            <a:ext cx="670560" cy="670560"/>
+            <a:off x="2156460" y="2994660"/>
+            <a:ext cx="563880" cy="563880"/>
           </a:xfrm>
           <a:prstGeom prst="ellipse">
             <a:avLst/>
@@ -12347,14 +12555,14 @@
       </p:sp>
       <p:sp>
         <p:nvSpPr>
-          <p:cNvPr id="24" name="Text 22"/>
-          <p:cNvSpPr/>
-          <p:nvPr/>
-        </p:nvSpPr>
-        <p:spPr>
-          <a:xfrm>
-            <a:off x="5334000" y="3238500"/>
-            <a:ext cx="1371600" cy="228600"/>
+          <p:cNvPr id="20" name="Text 18"/>
+          <p:cNvSpPr/>
+          <p:nvPr/>
+        </p:nvSpPr>
+        <p:spPr>
+          <a:xfrm>
+            <a:off x="1752600" y="2857500"/>
+            <a:ext cx="2133600" cy="228600"/>
           </a:xfrm>
           <a:prstGeom prst="rect">
             <a:avLst/>
@@ -12372,7 +12580,7 @@
               <a:buNone/>
             </a:pPr>
             <a:r>
-              <a:rPr lang="en-US" sz="1024" b="1" dirty="0">
+              <a:rPr lang="en-US" sz="896" b="1" dirty="0">
                 <a:solidFill>
                   <a:srgbClr val="F4F1E8"/>
                 </a:solidFill>
@@ -12380,22 +12588,22 @@
                 <a:ea typeface="Aptos" pitchFamily="34" charset="-122"/>
                 <a:cs typeface="Aptos" pitchFamily="34" charset="-120"/>
               </a:rPr>
-              <a:t>Kimi</a:t>
-            </a:r>
-            <a:endParaRPr lang="en-US" sz="1024" dirty="0"/>
-          </a:p>
-        </p:txBody>
-      </p:sp>
-      <p:sp>
-        <p:nvSpPr>
-          <p:cNvPr id="25" name="Shape 23"/>
-          <p:cNvSpPr/>
-          <p:nvPr/>
-        </p:nvSpPr>
-        <p:spPr>
-          <a:xfrm>
-            <a:off x="7444740" y="2148840"/>
-            <a:ext cx="502920" cy="502920"/>
+              <a:t>Kimi · 23/24 · $0.0013 · 17.6s</a:t>
+            </a:r>
+            <a:endParaRPr lang="en-US" sz="896" dirty="0"/>
+          </a:p>
+        </p:txBody>
+      </p:sp>
+      <p:sp>
+        <p:nvSpPr>
+          <p:cNvPr id="21" name="Shape 19"/>
+          <p:cNvSpPr/>
+          <p:nvPr/>
+        </p:nvSpPr>
+        <p:spPr>
+          <a:xfrm>
+            <a:off x="8039100" y="1943100"/>
+            <a:ext cx="381000" cy="381000"/>
           </a:xfrm>
           <a:prstGeom prst="ellipse">
             <a:avLst/>
@@ -12415,14 +12623,14 @@
       </p:sp>
       <p:sp>
         <p:nvSpPr>
-          <p:cNvPr id="26" name="Text 24"/>
-          <p:cNvSpPr/>
-          <p:nvPr/>
-        </p:nvSpPr>
-        <p:spPr>
-          <a:xfrm>
-            <a:off x="7239000" y="2773680"/>
-            <a:ext cx="1371600" cy="228600"/>
+          <p:cNvPr id="22" name="Text 20"/>
+          <p:cNvSpPr/>
+          <p:nvPr/>
+        </p:nvSpPr>
+        <p:spPr>
+          <a:xfrm>
+            <a:off x="7543800" y="2438400"/>
+            <a:ext cx="2133600" cy="228600"/>
           </a:xfrm>
           <a:prstGeom prst="rect">
             <a:avLst/>
@@ -12440,7 +12648,7 @@
               <a:buNone/>
             </a:pPr>
             <a:r>
-              <a:rPr lang="en-US" sz="1024" b="1" dirty="0">
+              <a:rPr lang="en-US" sz="896" b="1" dirty="0">
                 <a:solidFill>
                   <a:srgbClr val="F4F1E8"/>
                 </a:solidFill>
@@ -12448,15 +12656,15 @@
                 <a:ea typeface="Aptos" pitchFamily="34" charset="-122"/>
                 <a:cs typeface="Aptos" pitchFamily="34" charset="-120"/>
               </a:rPr>
-              <a:t>Claude</a:t>
-            </a:r>
-            <a:endParaRPr lang="en-US" sz="1024" dirty="0"/>
-          </a:p>
-        </p:txBody>
-      </p:sp>
-      <p:sp>
-        <p:nvSpPr>
-          <p:cNvPr id="27" name="Text 25"/>
+              <a:t>Claude · 24/24 · $0.0086 · 8.2s</a:t>
+            </a:r>
+            <a:endParaRPr lang="en-US" sz="896" dirty="0"/>
+          </a:p>
+        </p:txBody>
+      </p:sp>
+      <p:sp>
+        <p:nvSpPr>
+          <p:cNvPr id="23" name="Text 21"/>
           <p:cNvSpPr/>
           <p:nvPr/>
         </p:nvSpPr>
@@ -12514,14 +12722,318 @@
       </p:sp>
       <p:sp>
         <p:nvSpPr>
-          <p:cNvPr id="28" name="Shape 26"/>
-          <p:cNvSpPr/>
-          <p:nvPr/>
-        </p:nvSpPr>
-        <p:spPr>
-          <a:xfrm flipV="1">
-            <a:off x="1905000" y="3261360"/>
-            <a:ext cx="2362200" cy="990600"/>
+          <p:cNvPr id="24" name="Text 22"/>
+          <p:cNvSpPr/>
+          <p:nvPr/>
+        </p:nvSpPr>
+        <p:spPr>
+          <a:xfrm>
+            <a:off x="800100" y="5181600"/>
+            <a:ext cx="762000" cy="182880"/>
+          </a:xfrm>
+          <a:prstGeom prst="rect">
+            <a:avLst/>
+          </a:prstGeom>
+          <a:noFill/>
+          <a:ln/>
+        </p:spPr>
+        <p:txBody>
+          <a:bodyPr wrap="square" lIns="0" tIns="0" rIns="0" bIns="0" rtlCol="0" anchor="t">
+            <a:normAutofit/>
+          </a:bodyPr>
+          <a:lstStyle/>
+          <a:p>
+            <a:pPr algn="ctr" indent="0" marL="0">
+              <a:buNone/>
+            </a:pPr>
+            <a:r>
+              <a:rPr lang="en-US" sz="800" b="1" dirty="0">
+                <a:solidFill>
+                  <a:srgbClr val="A2B0C1"/>
+                </a:solidFill>
+                <a:latin typeface="Aptos Mono" pitchFamily="34" charset="0"/>
+                <a:ea typeface="Aptos Mono" pitchFamily="34" charset="-122"/>
+                <a:cs typeface="Aptos Mono" pitchFamily="34" charset="-120"/>
+              </a:rPr>
+              <a:t>$0</a:t>
+            </a:r>
+            <a:endParaRPr lang="en-US" sz="800" dirty="0"/>
+          </a:p>
+        </p:txBody>
+      </p:sp>
+      <p:sp>
+        <p:nvSpPr>
+          <p:cNvPr id="25" name="Text 23"/>
+          <p:cNvSpPr/>
+          <p:nvPr/>
+        </p:nvSpPr>
+        <p:spPr>
+          <a:xfrm>
+            <a:off x="4457700" y="5181600"/>
+            <a:ext cx="762000" cy="182880"/>
+          </a:xfrm>
+          <a:prstGeom prst="rect">
+            <a:avLst/>
+          </a:prstGeom>
+          <a:noFill/>
+          <a:ln/>
+        </p:spPr>
+        <p:txBody>
+          <a:bodyPr wrap="square" lIns="0" tIns="0" rIns="0" bIns="0" rtlCol="0" anchor="t">
+            <a:normAutofit/>
+          </a:bodyPr>
+          <a:lstStyle/>
+          <a:p>
+            <a:pPr algn="ctr" indent="0" marL="0">
+              <a:buNone/>
+            </a:pPr>
+            <a:r>
+              <a:rPr lang="en-US" sz="800" b="1" dirty="0">
+                <a:solidFill>
+                  <a:srgbClr val="A2B0C1"/>
+                </a:solidFill>
+                <a:latin typeface="Aptos Mono" pitchFamily="34" charset="0"/>
+                <a:ea typeface="Aptos Mono" pitchFamily="34" charset="-122"/>
+                <a:cs typeface="Aptos Mono" pitchFamily="34" charset="-120"/>
+              </a:rPr>
+              <a:t>$0.004</a:t>
+            </a:r>
+            <a:endParaRPr lang="en-US" sz="800" dirty="0"/>
+          </a:p>
+        </p:txBody>
+      </p:sp>
+      <p:sp>
+        <p:nvSpPr>
+          <p:cNvPr id="26" name="Text 24"/>
+          <p:cNvSpPr/>
+          <p:nvPr/>
+        </p:nvSpPr>
+        <p:spPr>
+          <a:xfrm>
+            <a:off x="8115300" y="5181600"/>
+            <a:ext cx="762000" cy="182880"/>
+          </a:xfrm>
+          <a:prstGeom prst="rect">
+            <a:avLst/>
+          </a:prstGeom>
+          <a:noFill/>
+          <a:ln/>
+        </p:spPr>
+        <p:txBody>
+          <a:bodyPr wrap="square" lIns="0" tIns="0" rIns="0" bIns="0" rtlCol="0" anchor="t">
+            <a:normAutofit/>
+          </a:bodyPr>
+          <a:lstStyle/>
+          <a:p>
+            <a:pPr algn="ctr" indent="0" marL="0">
+              <a:buNone/>
+            </a:pPr>
+            <a:r>
+              <a:rPr lang="en-US" sz="800" b="1" dirty="0">
+                <a:solidFill>
+                  <a:srgbClr val="A2B0C1"/>
+                </a:solidFill>
+                <a:latin typeface="Aptos Mono" pitchFamily="34" charset="0"/>
+                <a:ea typeface="Aptos Mono" pitchFamily="34" charset="-122"/>
+                <a:cs typeface="Aptos Mono" pitchFamily="34" charset="-120"/>
+              </a:rPr>
+              <a:t>$0.008</a:t>
+            </a:r>
+            <a:endParaRPr lang="en-US" sz="800" dirty="0"/>
+          </a:p>
+        </p:txBody>
+      </p:sp>
+      <p:sp>
+        <p:nvSpPr>
+          <p:cNvPr id="27" name="Text 25"/>
+          <p:cNvSpPr/>
+          <p:nvPr/>
+        </p:nvSpPr>
+        <p:spPr>
+          <a:xfrm>
+            <a:off x="624840" y="5029200"/>
+            <a:ext cx="426720" cy="182880"/>
+          </a:xfrm>
+          <a:prstGeom prst="rect">
+            <a:avLst/>
+          </a:prstGeom>
+          <a:noFill/>
+          <a:ln/>
+        </p:spPr>
+        <p:txBody>
+          <a:bodyPr wrap="square" lIns="0" tIns="0" rIns="0" bIns="0" rtlCol="0" anchor="t">
+            <a:normAutofit/>
+          </a:bodyPr>
+          <a:lstStyle/>
+          <a:p>
+            <a:pPr algn="r" indent="0" marL="0">
+              <a:buNone/>
+            </a:pPr>
+            <a:r>
+              <a:rPr lang="en-US" sz="800" b="1" dirty="0">
+                <a:solidFill>
+                  <a:srgbClr val="A2B0C1"/>
+                </a:solidFill>
+                <a:latin typeface="Aptos Mono" pitchFamily="34" charset="0"/>
+                <a:ea typeface="Aptos Mono" pitchFamily="34" charset="-122"/>
+                <a:cs typeface="Aptos Mono" pitchFamily="34" charset="-120"/>
+              </a:rPr>
+              <a:t>90%</a:t>
+            </a:r>
+            <a:endParaRPr lang="en-US" sz="800" dirty="0"/>
+          </a:p>
+        </p:txBody>
+      </p:sp>
+      <p:sp>
+        <p:nvSpPr>
+          <p:cNvPr id="28" name="Text 26"/>
+          <p:cNvSpPr/>
+          <p:nvPr/>
+        </p:nvSpPr>
+        <p:spPr>
+          <a:xfrm>
+            <a:off x="624840" y="3467100"/>
+            <a:ext cx="426720" cy="182880"/>
+          </a:xfrm>
+          <a:prstGeom prst="rect">
+            <a:avLst/>
+          </a:prstGeom>
+          <a:noFill/>
+          <a:ln/>
+        </p:spPr>
+        <p:txBody>
+          <a:bodyPr wrap="square" lIns="0" tIns="0" rIns="0" bIns="0" rtlCol="0" anchor="t">
+            <a:normAutofit/>
+          </a:bodyPr>
+          <a:lstStyle/>
+          <a:p>
+            <a:pPr algn="r" indent="0" marL="0">
+              <a:buNone/>
+            </a:pPr>
+            <a:r>
+              <a:rPr lang="en-US" sz="800" b="1" dirty="0">
+                <a:solidFill>
+                  <a:srgbClr val="A2B0C1"/>
+                </a:solidFill>
+                <a:latin typeface="Aptos Mono" pitchFamily="34" charset="0"/>
+                <a:ea typeface="Aptos Mono" pitchFamily="34" charset="-122"/>
+                <a:cs typeface="Aptos Mono" pitchFamily="34" charset="-120"/>
+              </a:rPr>
+              <a:t>95%</a:t>
+            </a:r>
+            <a:endParaRPr lang="en-US" sz="800" dirty="0"/>
+          </a:p>
+        </p:txBody>
+      </p:sp>
+      <p:sp>
+        <p:nvSpPr>
+          <p:cNvPr id="29" name="Text 27"/>
+          <p:cNvSpPr/>
+          <p:nvPr/>
+        </p:nvSpPr>
+        <p:spPr>
+          <a:xfrm>
+            <a:off x="624840" y="1905000"/>
+            <a:ext cx="426720" cy="182880"/>
+          </a:xfrm>
+          <a:prstGeom prst="rect">
+            <a:avLst/>
+          </a:prstGeom>
+          <a:noFill/>
+          <a:ln/>
+        </p:spPr>
+        <p:txBody>
+          <a:bodyPr wrap="square" lIns="0" tIns="0" rIns="0" bIns="0" rtlCol="0" anchor="t">
+            <a:normAutofit/>
+          </a:bodyPr>
+          <a:lstStyle/>
+          <a:p>
+            <a:pPr algn="r" indent="0" marL="0">
+              <a:buNone/>
+            </a:pPr>
+            <a:r>
+              <a:rPr lang="en-US" sz="800" b="1" dirty="0">
+                <a:solidFill>
+                  <a:srgbClr val="A2B0C1"/>
+                </a:solidFill>
+                <a:latin typeface="Aptos Mono" pitchFamily="34" charset="0"/>
+                <a:ea typeface="Aptos Mono" pitchFamily="34" charset="-122"/>
+                <a:cs typeface="Aptos Mono" pitchFamily="34" charset="-120"/>
+              </a:rPr>
+              <a:t>100%</a:t>
+            </a:r>
+            <a:endParaRPr lang="en-US" sz="800" dirty="0"/>
+          </a:p>
+        </p:txBody>
+      </p:sp>
+      <p:sp>
+        <p:nvSpPr>
+          <p:cNvPr id="30" name="Text 28"/>
+          <p:cNvSpPr/>
+          <p:nvPr/>
+        </p:nvSpPr>
+        <p:spPr>
+          <a:xfrm>
+            <a:off x="9486900" y="3124200"/>
+            <a:ext cx="1905000" cy="441960"/>
+          </a:xfrm>
+          <a:prstGeom prst="rect">
+            <a:avLst/>
+          </a:prstGeom>
+          <a:noFill/>
+          <a:ln/>
+        </p:spPr>
+        <p:txBody>
+          <a:bodyPr wrap="square" lIns="0" tIns="0" rIns="0" bIns="0" rtlCol="0" anchor="t">
+            <a:normAutofit/>
+          </a:bodyPr>
+          <a:lstStyle/>
+          <a:p>
+            <a:pPr algn="l" indent="0" marL="0">
+              <a:buNone/>
+            </a:pPr>
+            <a:r>
+              <a:rPr lang="en-US" sz="896" dirty="0">
+                <a:solidFill>
+                  <a:srgbClr val="A2B0C1"/>
+                </a:solidFill>
+                <a:latin typeface="Aptos" pitchFamily="34" charset="0"/>
+                <a:ea typeface="Aptos" pitchFamily="34" charset="-122"/>
+                <a:cs typeface="Aptos" pitchFamily="34" charset="-120"/>
+              </a:rPr>
+              <a:t>Y-axis shown from</a:t>
+            </a:r>
+            <a:endParaRPr lang="en-US" sz="896" dirty="0"/>
+          </a:p>
+          <a:p>
+            <a:pPr algn="l" indent="0" marL="0">
+              <a:buNone/>
+            </a:pPr>
+            <a:r>
+              <a:rPr lang="en-US" sz="896" dirty="0">
+                <a:solidFill>
+                  <a:srgbClr val="A2B0C1"/>
+                </a:solidFill>
+                <a:latin typeface="Aptos" pitchFamily="34" charset="0"/>
+                <a:ea typeface="Aptos" pitchFamily="34" charset="-122"/>
+                <a:cs typeface="Aptos" pitchFamily="34" charset="-120"/>
+              </a:rPr>
+              <a:t>90–100% eligible</a:t>
+            </a:r>
+            <a:endParaRPr lang="en-US" sz="896" dirty="0"/>
+          </a:p>
+        </p:txBody>
+      </p:sp>
+      <p:sp>
+        <p:nvSpPr>
+          <p:cNvPr id="31" name="Shape 29"/>
+          <p:cNvSpPr/>
+          <p:nvPr/>
+        </p:nvSpPr>
+        <p:spPr>
+          <a:xfrm>
+            <a:off x="1333500" y="3276600"/>
+            <a:ext cx="1104900" cy="0"/>
           </a:xfrm>
           <a:prstGeom prst="line">
             <a:avLst/>
@@ -12537,14 +13049,14 @@
       </p:sp>
       <p:sp>
         <p:nvSpPr>
-          <p:cNvPr id="29" name="Shape 27"/>
+          <p:cNvPr id="32" name="Shape 30"/>
           <p:cNvSpPr/>
           <p:nvPr/>
         </p:nvSpPr>
         <p:spPr>
           <a:xfrm flipV="1">
-            <a:off x="4267200" y="2766060"/>
-            <a:ext cx="1524000" cy="495300"/>
+            <a:off x="2438400" y="2133600"/>
+            <a:ext cx="5791200" cy="1143000"/>
           </a:xfrm>
           <a:prstGeom prst="line">
             <a:avLst/>
@@ -12560,36 +13072,13 @@
       </p:sp>
       <p:sp>
         <p:nvSpPr>
-          <p:cNvPr id="30" name="Shape 28"/>
-          <p:cNvSpPr/>
-          <p:nvPr/>
-        </p:nvSpPr>
-        <p:spPr>
-          <a:xfrm flipV="1">
-            <a:off x="5791200" y="2385060"/>
-            <a:ext cx="1905000" cy="381000"/>
-          </a:xfrm>
-          <a:prstGeom prst="line">
-            <a:avLst/>
-          </a:prstGeom>
-          <a:noFill/>
-          <a:ln w="25400">
-            <a:solidFill>
-              <a:srgbClr val="B7E36B"/>
-            </a:solidFill>
-            <a:prstDash val="solid"/>
-          </a:ln>
-        </p:spPr>
-      </p:sp>
-      <p:sp>
-        <p:nvSpPr>
-          <p:cNvPr id="31" name="Text 29"/>
-          <p:cNvSpPr/>
-          <p:nvPr/>
-        </p:nvSpPr>
-        <p:spPr>
-          <a:xfrm>
-            <a:off x="8229600" y="1943100"/>
+          <p:cNvPr id="33" name="Text 31"/>
+          <p:cNvSpPr/>
+          <p:nvPr/>
+        </p:nvSpPr>
+        <p:spPr>
+          <a:xfrm>
+            <a:off x="8229600" y="1790700"/>
             <a:ext cx="2514600" cy="259080"/>
           </a:xfrm>
           <a:prstGeom prst="rect">
@@ -12624,7 +13113,7 @@
       </p:sp>
       <p:sp>
         <p:nvSpPr>
-          <p:cNvPr id="32" name="Shape 30"/>
+          <p:cNvPr id="34" name="Shape 32"/>
           <p:cNvSpPr/>
           <p:nvPr/>
         </p:nvSpPr>
@@ -12649,7 +13138,7 @@
       </p:sp>
       <p:sp>
         <p:nvSpPr>
-          <p:cNvPr id="33" name="Text 31"/>
+          <p:cNvPr id="35" name="Text 33"/>
           <p:cNvSpPr/>
           <p:nvPr/>
         </p:nvSpPr>
@@ -13792,7 +14281,7 @@
                 <a:ea typeface="Aptos" pitchFamily="34" charset="-122"/>
                 <a:cs typeface="Aptos" pitchFamily="34" charset="-120"/>
               </a:rPr>
-              <a:t>Five real product states form a playable web sequence and a stepped PowerPoint fallback.</a:t>
+              <a:t>Three captured product states anchor a five-step workflow and its PowerPoint fallback.</a:t>
             </a:r>
             <a:endParaRPr lang="en-US" sz="1536" dirty="0"/>
           </a:p>
@@ -14573,6 +15062,47 @@
               <a:t>version +1</a:t>
             </a:r>
             <a:endParaRPr lang="en-US" sz="960" dirty="0"/>
+          </a:p>
+        </p:txBody>
+      </p:sp>
+      <p:sp>
+        <p:nvSpPr>
+          <p:cNvPr id="31" name="Text 26"/>
+          <p:cNvSpPr/>
+          <p:nvPr/>
+        </p:nvSpPr>
+        <p:spPr>
+          <a:xfrm>
+            <a:off x="609600" y="5410200"/>
+            <a:ext cx="10896600" cy="182880"/>
+          </a:xfrm>
+          <a:prstGeom prst="rect">
+            <a:avLst/>
+          </a:prstGeom>
+          <a:noFill/>
+          <a:ln/>
+        </p:spPr>
+        <p:txBody>
+          <a:bodyPr wrap="square" lIns="0" tIns="0" rIns="0" bIns="0" rtlCol="0" anchor="t">
+            <a:normAutofit/>
+          </a:bodyPr>
+          <a:lstStyle/>
+          <a:p>
+            <a:pPr algn="ctr" indent="0" marL="0">
+              <a:buNone/>
+            </a:pPr>
+            <a:r>
+              <a:rPr lang="en-US" sz="832" b="1" dirty="0">
+                <a:solidFill>
+                  <a:srgbClr val="A2B0C1"/>
+                </a:solidFill>
+                <a:latin typeface="Aptos Mono" pitchFamily="34" charset="0"/>
+                <a:ea typeface="Aptos Mono" pitchFamily="34" charset="-122"/>
+                <a:cs typeface="Aptos Mono" pitchFamily="34" charset="-120"/>
+              </a:rPr>
+              <a:t>3 captured checkpoints · 5 declared workflow steps</a:t>
+            </a:r>
+            <a:endParaRPr lang="en-US" sz="832" dirty="0"/>
           </a:p>
         </p:txBody>
       </p:sp>

</xml_diff>